<commit_message>
docs(ppt): unify all slides to light background
</commit_message>
<xml_diff>
--- a/SQL随身教练-汇报.pptx
+++ b/SQL随身教练-汇报.pptx
@@ -8139,7 +8139,7 @@
     <p:bg>
       <p:bgPr>
         <a:solidFill>
-          <a:srgbClr val="0F172A"/>
+          <a:srgbClr val="F8FAFC"/>
         </a:solidFill>
       </p:bgPr>
     </p:bg>
@@ -8166,7 +8166,7 @@
         <p:spPr>
           <a:xfrm>
             <a:off x="0" y="0"/>
-            <a:ext cx="9144000" cy="54864"/>
+            <a:ext cx="9144000" cy="45720"/>
           </a:xfrm>
           <a:prstGeom prst="rect">
             <a:avLst/>
@@ -8185,7 +8185,7 @@
         </p:nvSpPr>
         <p:spPr>
           <a:xfrm>
-            <a:off x="548640" y="228600"/>
+            <a:off x="548640" y="201168"/>
             <a:ext cx="8046720" cy="548640"/>
           </a:xfrm>
           <a:prstGeom prst="rect">
@@ -8202,9 +8202,9 @@
               <a:buNone/>
             </a:pPr>
             <a:r>
-              <a:rPr lang="en-US" sz="2800" b="1" dirty="0">
-                <a:solidFill>
-                  <a:srgbClr val="F1F5F9"/>
+              <a:rPr lang="en-US" sz="2600" b="1" dirty="0">
+                <a:solidFill>
+                  <a:srgbClr val="1E293B"/>
                 </a:solidFill>
                 <a:latin typeface="Arial Black" pitchFamily="34" charset="0"/>
                 <a:ea typeface="Arial Black" pitchFamily="34" charset="-122"/>
@@ -8212,7 +8212,7 @@
               </a:rPr>
               <a:t>总结与展望</a:t>
             </a:r>
-            <a:endParaRPr lang="en-US" sz="2800" dirty="0"/>
+            <a:endParaRPr lang="en-US" sz="2600" dirty="0"/>
           </a:p>
         </p:txBody>
       </p:sp>
@@ -8224,24 +8224,24 @@
         </p:nvSpPr>
         <p:spPr>
           <a:xfrm>
-            <a:off x="548640" y="749808"/>
-            <a:ext cx="8046720" cy="274320"/>
-          </a:xfrm>
-          <a:prstGeom prst="rect">
-            <a:avLst/>
-          </a:prstGeom>
-          <a:noFill/>
-          <a:ln/>
-        </p:spPr>
-        <p:txBody>
-          <a:bodyPr wrap="square" lIns="0" tIns="0" rIns="0" bIns="0" rtlCol="0" anchor="ctr"/>
-          <a:lstStyle/>
-          <a:p>
-            <a:pPr indent="0" marL="0">
-              <a:buNone/>
-            </a:pPr>
-            <a:r>
-              <a:rPr lang="en-US" sz="1200" dirty="0">
+            <a:off x="548640" y="713232"/>
+            <a:ext cx="8046720" cy="292608"/>
+          </a:xfrm>
+          <a:prstGeom prst="rect">
+            <a:avLst/>
+          </a:prstGeom>
+          <a:noFill/>
+          <a:ln/>
+        </p:spPr>
+        <p:txBody>
+          <a:bodyPr wrap="square" lIns="0" tIns="0" rIns="0" bIns="0" rtlCol="0" anchor="ctr"/>
+          <a:lstStyle/>
+          <a:p>
+            <a:pPr indent="0" marL="0">
+              <a:buNone/>
+            </a:pPr>
+            <a:r>
+              <a:rPr lang="en-US" sz="1300" dirty="0">
                 <a:solidFill>
                   <a:srgbClr val="94A3B8"/>
                 </a:solidFill>
@@ -8251,7 +8251,7 @@
               </a:rPr>
               <a:t>感谢倾听 · 期待您的建议</a:t>
             </a:r>
-            <a:endParaRPr lang="en-US" sz="1200" dirty="0"/>
+            <a:endParaRPr lang="en-US" sz="1300" dirty="0"/>
           </a:p>
         </p:txBody>
       </p:sp>
@@ -8263,7 +8263,7 @@
         </p:nvSpPr>
         <p:spPr>
           <a:xfrm>
-            <a:off x="548640" y="1051560"/>
+            <a:off x="548640" y="1024128"/>
             <a:ext cx="914400" cy="0"/>
           </a:xfrm>
           <a:prstGeom prst="line">
@@ -8327,7 +8327,7 @@
             <a:r>
               <a:rPr lang="en-US" sz="1800" b="1" dirty="0">
                 <a:solidFill>
-                  <a:srgbClr val="34D399"/>
+                  <a:srgbClr val="059669"/>
                 </a:solidFill>
                 <a:latin typeface="Microsoft YaHei" pitchFamily="34" charset="0"/>
                 <a:ea typeface="Microsoft YaHei" pitchFamily="34" charset="-122"/>
@@ -8366,7 +8366,7 @@
             <a:r>
               <a:rPr lang="en-US" sz="1200" dirty="0">
                 <a:solidFill>
-                  <a:srgbClr val="34D399"/>
+                  <a:srgbClr val="059669"/>
                 </a:solidFill>
                 <a:latin typeface="Microsoft YaHei" pitchFamily="34" charset="0"/>
                 <a:ea typeface="Microsoft YaHei" pitchFamily="34" charset="-122"/>
@@ -8380,7 +8380,7 @@
             <a:r>
               <a:rPr lang="en-US" sz="1200" dirty="0">
                 <a:solidFill>
-                  <a:srgbClr val="94A3B8"/>
+                  <a:srgbClr val="1E293B"/>
                 </a:solidFill>
                 <a:latin typeface="Microsoft YaHei" pitchFamily="34" charset="0"/>
                 <a:ea typeface="Microsoft YaHei" pitchFamily="34" charset="-122"/>
@@ -8419,7 +8419,7 @@
             <a:r>
               <a:rPr lang="en-US" sz="1200" dirty="0">
                 <a:solidFill>
-                  <a:srgbClr val="34D399"/>
+                  <a:srgbClr val="059669"/>
                 </a:solidFill>
                 <a:latin typeface="Microsoft YaHei" pitchFamily="34" charset="0"/>
                 <a:ea typeface="Microsoft YaHei" pitchFamily="34" charset="-122"/>
@@ -8433,7 +8433,7 @@
             <a:r>
               <a:rPr lang="en-US" sz="1200" dirty="0">
                 <a:solidFill>
-                  <a:srgbClr val="94A3B8"/>
+                  <a:srgbClr val="1E293B"/>
                 </a:solidFill>
                 <a:latin typeface="Microsoft YaHei" pitchFamily="34" charset="0"/>
                 <a:ea typeface="Microsoft YaHei" pitchFamily="34" charset="-122"/>
@@ -8472,7 +8472,7 @@
             <a:r>
               <a:rPr lang="en-US" sz="1200" dirty="0">
                 <a:solidFill>
-                  <a:srgbClr val="34D399"/>
+                  <a:srgbClr val="059669"/>
                 </a:solidFill>
                 <a:latin typeface="Microsoft YaHei" pitchFamily="34" charset="0"/>
                 <a:ea typeface="Microsoft YaHei" pitchFamily="34" charset="-122"/>
@@ -8486,7 +8486,7 @@
             <a:r>
               <a:rPr lang="en-US" sz="1200" dirty="0">
                 <a:solidFill>
-                  <a:srgbClr val="94A3B8"/>
+                  <a:srgbClr val="1E293B"/>
                 </a:solidFill>
                 <a:latin typeface="Microsoft YaHei" pitchFamily="34" charset="0"/>
                 <a:ea typeface="Microsoft YaHei" pitchFamily="34" charset="-122"/>
@@ -8525,7 +8525,7 @@
             <a:r>
               <a:rPr lang="en-US" sz="1200" dirty="0">
                 <a:solidFill>
-                  <a:srgbClr val="34D399"/>
+                  <a:srgbClr val="059669"/>
                 </a:solidFill>
                 <a:latin typeface="Microsoft YaHei" pitchFamily="34" charset="0"/>
                 <a:ea typeface="Microsoft YaHei" pitchFamily="34" charset="-122"/>
@@ -8539,7 +8539,7 @@
             <a:r>
               <a:rPr lang="en-US" sz="1200" dirty="0">
                 <a:solidFill>
-                  <a:srgbClr val="94A3B8"/>
+                  <a:srgbClr val="1E293B"/>
                 </a:solidFill>
                 <a:latin typeface="Microsoft YaHei" pitchFamily="34" charset="0"/>
                 <a:ea typeface="Microsoft YaHei" pitchFamily="34" charset="-122"/>
@@ -8578,7 +8578,7 @@
             <a:r>
               <a:rPr lang="en-US" sz="1200" dirty="0">
                 <a:solidFill>
-                  <a:srgbClr val="34D399"/>
+                  <a:srgbClr val="059669"/>
                 </a:solidFill>
                 <a:latin typeface="Microsoft YaHei" pitchFamily="34" charset="0"/>
                 <a:ea typeface="Microsoft YaHei" pitchFamily="34" charset="-122"/>
@@ -8592,7 +8592,7 @@
             <a:r>
               <a:rPr lang="en-US" sz="1200" dirty="0">
                 <a:solidFill>
-                  <a:srgbClr val="94A3B8"/>
+                  <a:srgbClr val="1E293B"/>
                 </a:solidFill>
                 <a:latin typeface="Microsoft YaHei" pitchFamily="34" charset="0"/>
                 <a:ea typeface="Microsoft YaHei" pitchFamily="34" charset="-122"/>
@@ -8631,7 +8631,7 @@
             <a:r>
               <a:rPr lang="en-US" sz="1200" dirty="0">
                 <a:solidFill>
-                  <a:srgbClr val="34D399"/>
+                  <a:srgbClr val="059669"/>
                 </a:solidFill>
                 <a:latin typeface="Microsoft YaHei" pitchFamily="34" charset="0"/>
                 <a:ea typeface="Microsoft YaHei" pitchFamily="34" charset="-122"/>
@@ -8645,7 +8645,7 @@
             <a:r>
               <a:rPr lang="en-US" sz="1200" dirty="0">
                 <a:solidFill>
-                  <a:srgbClr val="94A3B8"/>
+                  <a:srgbClr val="1E293B"/>
                 </a:solidFill>
                 <a:latin typeface="Microsoft YaHei" pitchFamily="34" charset="0"/>
                 <a:ea typeface="Microsoft YaHei" pitchFamily="34" charset="-122"/>
@@ -8684,7 +8684,7 @@
             <a:r>
               <a:rPr lang="en-US" sz="1200" dirty="0">
                 <a:solidFill>
-                  <a:srgbClr val="34D399"/>
+                  <a:srgbClr val="059669"/>
                 </a:solidFill>
                 <a:latin typeface="Microsoft YaHei" pitchFamily="34" charset="0"/>
                 <a:ea typeface="Microsoft YaHei" pitchFamily="34" charset="-122"/>
@@ -8698,7 +8698,7 @@
             <a:r>
               <a:rPr lang="en-US" sz="1200" dirty="0">
                 <a:solidFill>
-                  <a:srgbClr val="94A3B8"/>
+                  <a:srgbClr val="1E293B"/>
                 </a:solidFill>
                 <a:latin typeface="Microsoft YaHei" pitchFamily="34" charset="0"/>
                 <a:ea typeface="Microsoft YaHei" pitchFamily="34" charset="-122"/>
@@ -8737,7 +8737,7 @@
             <a:r>
               <a:rPr lang="en-US" sz="1800" b="1" dirty="0">
                 <a:solidFill>
-                  <a:srgbClr val="FBBF24"/>
+                  <a:srgbClr val="D97706"/>
                 </a:solidFill>
                 <a:latin typeface="Microsoft YaHei" pitchFamily="34" charset="0"/>
                 <a:ea typeface="Microsoft YaHei" pitchFamily="34" charset="-122"/>
@@ -8776,7 +8776,7 @@
             <a:r>
               <a:rPr lang="en-US" sz="1200" dirty="0">
                 <a:solidFill>
-                  <a:srgbClr val="FBBF24"/>
+                  <a:srgbClr val="D97706"/>
                 </a:solidFill>
                 <a:latin typeface="Microsoft YaHei" pitchFamily="34" charset="0"/>
                 <a:ea typeface="Microsoft YaHei" pitchFamily="34" charset="-122"/>
@@ -8790,7 +8790,7 @@
             <a:r>
               <a:rPr lang="en-US" sz="1200" dirty="0">
                 <a:solidFill>
-                  <a:srgbClr val="94A3B8"/>
+                  <a:srgbClr val="1E293B"/>
                 </a:solidFill>
                 <a:latin typeface="Microsoft YaHei" pitchFamily="34" charset="0"/>
                 <a:ea typeface="Microsoft YaHei" pitchFamily="34" charset="-122"/>
@@ -8829,7 +8829,7 @@
             <a:r>
               <a:rPr lang="en-US" sz="1200" dirty="0">
                 <a:solidFill>
-                  <a:srgbClr val="FBBF24"/>
+                  <a:srgbClr val="D97706"/>
                 </a:solidFill>
                 <a:latin typeface="Microsoft YaHei" pitchFamily="34" charset="0"/>
                 <a:ea typeface="Microsoft YaHei" pitchFamily="34" charset="-122"/>
@@ -8843,7 +8843,7 @@
             <a:r>
               <a:rPr lang="en-US" sz="1200" dirty="0">
                 <a:solidFill>
-                  <a:srgbClr val="94A3B8"/>
+                  <a:srgbClr val="1E293B"/>
                 </a:solidFill>
                 <a:latin typeface="Microsoft YaHei" pitchFamily="34" charset="0"/>
                 <a:ea typeface="Microsoft YaHei" pitchFamily="34" charset="-122"/>
@@ -8882,7 +8882,7 @@
             <a:r>
               <a:rPr lang="en-US" sz="1200" dirty="0">
                 <a:solidFill>
-                  <a:srgbClr val="FBBF24"/>
+                  <a:srgbClr val="D97706"/>
                 </a:solidFill>
                 <a:latin typeface="Microsoft YaHei" pitchFamily="34" charset="0"/>
                 <a:ea typeface="Microsoft YaHei" pitchFamily="34" charset="-122"/>
@@ -8896,7 +8896,7 @@
             <a:r>
               <a:rPr lang="en-US" sz="1200" dirty="0">
                 <a:solidFill>
-                  <a:srgbClr val="94A3B8"/>
+                  <a:srgbClr val="1E293B"/>
                 </a:solidFill>
                 <a:latin typeface="Microsoft YaHei" pitchFamily="34" charset="0"/>
                 <a:ea typeface="Microsoft YaHei" pitchFamily="34" charset="-122"/>
@@ -8935,7 +8935,7 @@
             <a:r>
               <a:rPr lang="en-US" sz="1200" dirty="0">
                 <a:solidFill>
-                  <a:srgbClr val="FBBF24"/>
+                  <a:srgbClr val="D97706"/>
                 </a:solidFill>
                 <a:latin typeface="Microsoft YaHei" pitchFamily="34" charset="0"/>
                 <a:ea typeface="Microsoft YaHei" pitchFamily="34" charset="-122"/>
@@ -8949,7 +8949,7 @@
             <a:r>
               <a:rPr lang="en-US" sz="1200" dirty="0">
                 <a:solidFill>
-                  <a:srgbClr val="94A3B8"/>
+                  <a:srgbClr val="1E293B"/>
                 </a:solidFill>
                 <a:latin typeface="Microsoft YaHei" pitchFamily="34" charset="0"/>
                 <a:ea typeface="Microsoft YaHei" pitchFamily="34" charset="-122"/>
@@ -8988,7 +8988,7 @@
             <a:r>
               <a:rPr lang="en-US" sz="1200" dirty="0">
                 <a:solidFill>
-                  <a:srgbClr val="FBBF24"/>
+                  <a:srgbClr val="D97706"/>
                 </a:solidFill>
                 <a:latin typeface="Microsoft YaHei" pitchFamily="34" charset="0"/>
                 <a:ea typeface="Microsoft YaHei" pitchFamily="34" charset="-122"/>
@@ -9002,7 +9002,7 @@
             <a:r>
               <a:rPr lang="en-US" sz="1200" dirty="0">
                 <a:solidFill>
-                  <a:srgbClr val="94A3B8"/>
+                  <a:srgbClr val="1E293B"/>
                 </a:solidFill>
                 <a:latin typeface="Microsoft YaHei" pitchFamily="34" charset="0"/>
                 <a:ea typeface="Microsoft YaHei" pitchFamily="34" charset="-122"/>
@@ -9041,7 +9041,7 @@
             <a:r>
               <a:rPr lang="en-US" sz="1200" dirty="0">
                 <a:solidFill>
-                  <a:srgbClr val="FBBF24"/>
+                  <a:srgbClr val="D97706"/>
                 </a:solidFill>
                 <a:latin typeface="Microsoft YaHei" pitchFamily="34" charset="0"/>
                 <a:ea typeface="Microsoft YaHei" pitchFamily="34" charset="-122"/>
@@ -9055,7 +9055,7 @@
             <a:r>
               <a:rPr lang="en-US" sz="1200" dirty="0">
                 <a:solidFill>
-                  <a:srgbClr val="94A3B8"/>
+                  <a:srgbClr val="1E293B"/>
                 </a:solidFill>
                 <a:latin typeface="Microsoft YaHei" pitchFamily="34" charset="0"/>
                 <a:ea typeface="Microsoft YaHei" pitchFamily="34" charset="-122"/>
@@ -9094,7 +9094,7 @@
             <a:r>
               <a:rPr lang="en-US" sz="1200" dirty="0">
                 <a:solidFill>
-                  <a:srgbClr val="FBBF24"/>
+                  <a:srgbClr val="D97706"/>
                 </a:solidFill>
                 <a:latin typeface="Microsoft YaHei" pitchFamily="34" charset="0"/>
                 <a:ea typeface="Microsoft YaHei" pitchFamily="34" charset="-122"/>
@@ -9108,7 +9108,7 @@
             <a:r>
               <a:rPr lang="en-US" sz="1200" dirty="0">
                 <a:solidFill>
-                  <a:srgbClr val="94A3B8"/>
+                  <a:srgbClr val="1E293B"/>
                 </a:solidFill>
                 <a:latin typeface="Microsoft YaHei" pitchFamily="34" charset="0"/>
                 <a:ea typeface="Microsoft YaHei" pitchFamily="34" charset="-122"/>
@@ -9135,7 +9135,7 @@
             <a:avLst/>
           </a:prstGeom>
           <a:solidFill>
-            <a:srgbClr val="1E293B"/>
+            <a:srgbClr val="EFF6FF"/>
           </a:solidFill>
           <a:ln/>
         </p:spPr>
@@ -9167,7 +9167,7 @@
             <a:r>
               <a:rPr lang="en-US" sz="1100" dirty="0">
                 <a:solidFill>
-                  <a:srgbClr val="94A3B8"/>
+                  <a:srgbClr val="1D4ED8"/>
                 </a:solidFill>
                 <a:latin typeface="Microsoft YaHei" pitchFamily="34" charset="0"/>
                 <a:ea typeface="Microsoft YaHei" pitchFamily="34" charset="-122"/>
@@ -10457,7 +10457,7 @@
     <p:bg>
       <p:bgPr>
         <a:solidFill>
-          <a:srgbClr val="0F172A"/>
+          <a:srgbClr val="F8FAFC"/>
         </a:solidFill>
       </p:bgPr>
     </p:bg>
@@ -10484,7 +10484,7 @@
         <p:spPr>
           <a:xfrm>
             <a:off x="0" y="0"/>
-            <a:ext cx="9144000" cy="54864"/>
+            <a:ext cx="9144000" cy="45720"/>
           </a:xfrm>
           <a:prstGeom prst="rect">
             <a:avLst/>
@@ -10503,7 +10503,7 @@
         </p:nvSpPr>
         <p:spPr>
           <a:xfrm>
-            <a:off x="548640" y="228600"/>
+            <a:off x="548640" y="201168"/>
             <a:ext cx="8046720" cy="548640"/>
           </a:xfrm>
           <a:prstGeom prst="rect">
@@ -10520,9 +10520,9 @@
               <a:buNone/>
             </a:pPr>
             <a:r>
-              <a:rPr lang="en-US" sz="2800" b="1" dirty="0">
-                <a:solidFill>
-                  <a:srgbClr val="F1F5F9"/>
+              <a:rPr lang="en-US" sz="2600" b="1" dirty="0">
+                <a:solidFill>
+                  <a:srgbClr val="1E293B"/>
                 </a:solidFill>
                 <a:latin typeface="Arial Black" pitchFamily="34" charset="0"/>
                 <a:ea typeface="Arial Black" pitchFamily="34" charset="-122"/>
@@ -10530,7 +10530,7 @@
               </a:rPr>
               <a:t>系统架构与技术栈</a:t>
             </a:r>
-            <a:endParaRPr lang="en-US" sz="2800" dirty="0"/>
+            <a:endParaRPr lang="en-US" sz="2600" dirty="0"/>
           </a:p>
         </p:txBody>
       </p:sp>
@@ -10542,24 +10542,24 @@
         </p:nvSpPr>
         <p:spPr>
           <a:xfrm>
-            <a:off x="548640" y="749808"/>
-            <a:ext cx="8046720" cy="274320"/>
-          </a:xfrm>
-          <a:prstGeom prst="rect">
-            <a:avLst/>
-          </a:prstGeom>
-          <a:noFill/>
-          <a:ln/>
-        </p:spPr>
-        <p:txBody>
-          <a:bodyPr wrap="square" lIns="0" tIns="0" rIns="0" bIns="0" rtlCol="0" anchor="ctr"/>
-          <a:lstStyle/>
-          <a:p>
-            <a:pPr indent="0" marL="0">
-              <a:buNone/>
-            </a:pPr>
-            <a:r>
-              <a:rPr lang="en-US" sz="1200" dirty="0">
+            <a:off x="548640" y="713232"/>
+            <a:ext cx="8046720" cy="292608"/>
+          </a:xfrm>
+          <a:prstGeom prst="rect">
+            <a:avLst/>
+          </a:prstGeom>
+          <a:noFill/>
+          <a:ln/>
+        </p:spPr>
+        <p:txBody>
+          <a:bodyPr wrap="square" lIns="0" tIns="0" rIns="0" bIns="0" rtlCol="0" anchor="ctr"/>
+          <a:lstStyle/>
+          <a:p>
+            <a:pPr indent="0" marL="0">
+              <a:buNone/>
+            </a:pPr>
+            <a:r>
+              <a:rPr lang="en-US" sz="1300" dirty="0">
                 <a:solidFill>
                   <a:srgbClr val="94A3B8"/>
                 </a:solidFill>
@@ -10569,7 +10569,7 @@
               </a:rPr>
               <a:t>5 层架构 · 单一外部依赖（LLM API）</a:t>
             </a:r>
-            <a:endParaRPr lang="en-US" sz="1200" dirty="0"/>
+            <a:endParaRPr lang="en-US" sz="1300" dirty="0"/>
           </a:p>
         </p:txBody>
       </p:sp>
@@ -10581,7 +10581,7 @@
         </p:nvSpPr>
         <p:spPr>
           <a:xfrm>
-            <a:off x="548640" y="1051560"/>
+            <a:off x="548640" y="1024128"/>
             <a:ext cx="914400" cy="0"/>
           </a:xfrm>
           <a:prstGeom prst="line">
@@ -10611,7 +10611,7 @@
             <a:avLst/>
           </a:prstGeom>
           <a:solidFill>
-            <a:srgbClr val="1E293B"/>
+            <a:srgbClr val="FFFFFF"/>
           </a:solidFill>
           <a:ln/>
           <a:effectLst>
@@ -10736,7 +10736,7 @@
             <a:avLst/>
           </a:prstGeom>
           <a:solidFill>
-            <a:srgbClr val="1E293B"/>
+            <a:srgbClr val="FFFFFF"/>
           </a:solidFill>
           <a:ln/>
           <a:effectLst>
@@ -10763,7 +10763,7 @@
             <a:avLst/>
           </a:prstGeom>
           <a:solidFill>
-            <a:srgbClr val="38BDF8"/>
+            <a:srgbClr val="2563EB"/>
           </a:solidFill>
           <a:ln/>
         </p:spPr>
@@ -10795,7 +10795,7 @@
             <a:r>
               <a:rPr lang="en-US" sz="1300" b="1" dirty="0">
                 <a:solidFill>
-                  <a:srgbClr val="38BDF8"/>
+                  <a:srgbClr val="2563EB"/>
                 </a:solidFill>
                 <a:latin typeface="Microsoft YaHei" pitchFamily="34" charset="0"/>
                 <a:ea typeface="Microsoft YaHei" pitchFamily="34" charset="-122"/>
@@ -10861,7 +10861,7 @@
             <a:avLst/>
           </a:prstGeom>
           <a:solidFill>
-            <a:srgbClr val="1E293B"/>
+            <a:srgbClr val="FFFFFF"/>
           </a:solidFill>
           <a:ln/>
           <a:effectLst>
@@ -10888,7 +10888,7 @@
             <a:avLst/>
           </a:prstGeom>
           <a:solidFill>
-            <a:srgbClr val="34D399"/>
+            <a:srgbClr val="059669"/>
           </a:solidFill>
           <a:ln/>
         </p:spPr>
@@ -10920,7 +10920,7 @@
             <a:r>
               <a:rPr lang="en-US" sz="1300" b="1" dirty="0">
                 <a:solidFill>
-                  <a:srgbClr val="34D399"/>
+                  <a:srgbClr val="059669"/>
                 </a:solidFill>
                 <a:latin typeface="Microsoft YaHei" pitchFamily="34" charset="0"/>
                 <a:ea typeface="Microsoft YaHei" pitchFamily="34" charset="-122"/>
@@ -10986,7 +10986,7 @@
             <a:avLst/>
           </a:prstGeom>
           <a:solidFill>
-            <a:srgbClr val="1E293B"/>
+            <a:srgbClr val="FFFFFF"/>
           </a:solidFill>
           <a:ln/>
           <a:effectLst>
@@ -11013,7 +11013,7 @@
             <a:avLst/>
           </a:prstGeom>
           <a:solidFill>
-            <a:srgbClr val="FBBF24"/>
+            <a:srgbClr val="D97706"/>
           </a:solidFill>
           <a:ln/>
         </p:spPr>
@@ -11045,7 +11045,7 @@
             <a:r>
               <a:rPr lang="en-US" sz="1300" b="1" dirty="0">
                 <a:solidFill>
-                  <a:srgbClr val="FBBF24"/>
+                  <a:srgbClr val="D97706"/>
                 </a:solidFill>
                 <a:latin typeface="Microsoft YaHei" pitchFamily="34" charset="0"/>
                 <a:ea typeface="Microsoft YaHei" pitchFamily="34" charset="-122"/>
@@ -11111,7 +11111,7 @@
             <a:avLst/>
           </a:prstGeom>
           <a:solidFill>
-            <a:srgbClr val="1E293B"/>
+            <a:srgbClr val="FFFFFF"/>
           </a:solidFill>
           <a:ln/>
           <a:effectLst>
@@ -11138,7 +11138,7 @@
             <a:avLst/>
           </a:prstGeom>
           <a:solidFill>
-            <a:srgbClr val="F472B6"/>
+            <a:srgbClr val="DB2777"/>
           </a:solidFill>
           <a:ln/>
         </p:spPr>
@@ -11170,7 +11170,7 @@
             <a:r>
               <a:rPr lang="en-US" sz="1300" b="1" dirty="0">
                 <a:solidFill>
-                  <a:srgbClr val="F472B6"/>
+                  <a:srgbClr val="DB2777"/>
                 </a:solidFill>
                 <a:latin typeface="Microsoft YaHei" pitchFamily="34" charset="0"/>
                 <a:ea typeface="Microsoft YaHei" pitchFamily="34" charset="-122"/>
@@ -16060,7 +16060,7 @@
     <p:bg>
       <p:bgPr>
         <a:solidFill>
-          <a:srgbClr val="0F172A"/>
+          <a:srgbClr val="F8FAFC"/>
         </a:solidFill>
       </p:bgPr>
     </p:bg>
@@ -16087,7 +16087,7 @@
         <p:spPr>
           <a:xfrm>
             <a:off x="0" y="0"/>
-            <a:ext cx="9144000" cy="54864"/>
+            <a:ext cx="9144000" cy="45720"/>
           </a:xfrm>
           <a:prstGeom prst="rect">
             <a:avLst/>
@@ -16106,7 +16106,7 @@
         </p:nvSpPr>
         <p:spPr>
           <a:xfrm>
-            <a:off x="548640" y="228600"/>
+            <a:off x="548640" y="201168"/>
             <a:ext cx="8046720" cy="548640"/>
           </a:xfrm>
           <a:prstGeom prst="rect">
@@ -16123,9 +16123,9 @@
               <a:buNone/>
             </a:pPr>
             <a:r>
-              <a:rPr lang="en-US" sz="2800" b="1" dirty="0">
-                <a:solidFill>
-                  <a:srgbClr val="F1F5F9"/>
+              <a:rPr lang="en-US" sz="2600" b="1" dirty="0">
+                <a:solidFill>
+                  <a:srgbClr val="1E293B"/>
                 </a:solidFill>
                 <a:latin typeface="Arial Black" pitchFamily="34" charset="0"/>
                 <a:ea typeface="Arial Black" pitchFamily="34" charset="-122"/>
@@ -16133,7 +16133,7 @@
               </a:rPr>
               <a:t>亮点 3 · 三层判题引擎</a:t>
             </a:r>
-            <a:endParaRPr lang="en-US" sz="2800" dirty="0"/>
+            <a:endParaRPr lang="en-US" sz="2600" dirty="0"/>
           </a:p>
         </p:txBody>
       </p:sp>
@@ -16145,24 +16145,24 @@
         </p:nvSpPr>
         <p:spPr>
           <a:xfrm>
-            <a:off x="548640" y="749808"/>
-            <a:ext cx="8046720" cy="274320"/>
-          </a:xfrm>
-          <a:prstGeom prst="rect">
-            <a:avLst/>
-          </a:prstGeom>
-          <a:noFill/>
-          <a:ln/>
-        </p:spPr>
-        <p:txBody>
-          <a:bodyPr wrap="square" lIns="0" tIns="0" rIns="0" bIns="0" rtlCol="0" anchor="ctr"/>
-          <a:lstStyle/>
-          <a:p>
-            <a:pPr indent="0" marL="0">
-              <a:buNone/>
-            </a:pPr>
-            <a:r>
-              <a:rPr lang="en-US" sz="1200" dirty="0">
+            <a:off x="548640" y="713232"/>
+            <a:ext cx="8046720" cy="292608"/>
+          </a:xfrm>
+          <a:prstGeom prst="rect">
+            <a:avLst/>
+          </a:prstGeom>
+          <a:noFill/>
+          <a:ln/>
+        </p:spPr>
+        <p:txBody>
+          <a:bodyPr wrap="square" lIns="0" tIns="0" rIns="0" bIns="0" rtlCol="0" anchor="ctr"/>
+          <a:lstStyle/>
+          <a:p>
+            <a:pPr indent="0" marL="0">
+              <a:buNone/>
+            </a:pPr>
+            <a:r>
+              <a:rPr lang="en-US" sz="1300" dirty="0">
                 <a:solidFill>
                   <a:srgbClr val="94A3B8"/>
                 </a:solidFill>
@@ -16172,7 +16172,7 @@
               </a:rPr>
               <a:t>默认快速路径 ~50ms · 可选 LLM 语义复核</a:t>
             </a:r>
-            <a:endParaRPr lang="en-US" sz="1200" dirty="0"/>
+            <a:endParaRPr lang="en-US" sz="1300" dirty="0"/>
           </a:p>
         </p:txBody>
       </p:sp>
@@ -16184,7 +16184,7 @@
         </p:nvSpPr>
         <p:spPr>
           <a:xfrm>
-            <a:off x="548640" y="1051560"/>
+            <a:off x="548640" y="1024128"/>
             <a:ext cx="914400" cy="0"/>
           </a:xfrm>
           <a:prstGeom prst="line">
@@ -16214,7 +16214,7 @@
             <a:avLst/>
           </a:prstGeom>
           <a:solidFill>
-            <a:srgbClr val="1E293B"/>
+            <a:srgbClr val="FFFFFF"/>
           </a:solidFill>
           <a:ln/>
           <a:effectLst>
@@ -16241,7 +16241,7 @@
             <a:avLst/>
           </a:prstGeom>
           <a:solidFill>
-            <a:srgbClr val="38BDF8"/>
+            <a:srgbClr val="2563EB"/>
           </a:solidFill>
           <a:ln/>
         </p:spPr>
@@ -16261,7 +16261,7 @@
             <a:avLst/>
           </a:prstGeom>
           <a:solidFill>
-            <a:srgbClr val="38BDF8"/>
+            <a:srgbClr val="2563EB"/>
           </a:solidFill>
           <a:ln/>
         </p:spPr>
@@ -16293,7 +16293,7 @@
             <a:r>
               <a:rPr lang="en-US" sz="2200" b="1" dirty="0">
                 <a:solidFill>
-                  <a:srgbClr val="0F172A"/>
+                  <a:srgbClr val="FFFFFF"/>
                 </a:solidFill>
               </a:rPr>
               <a:t>1</a:t>
@@ -16329,7 +16329,7 @@
             <a:r>
               <a:rPr lang="en-US" sz="1600" b="1" dirty="0">
                 <a:solidFill>
-                  <a:srgbClr val="38BDF8"/>
+                  <a:srgbClr val="2563EB"/>
                 </a:solidFill>
                 <a:latin typeface="Microsoft YaHei" pitchFamily="34" charset="0"/>
                 <a:ea typeface="Microsoft YaHei" pitchFamily="34" charset="-122"/>
@@ -16412,7 +16412,7 @@
             <a:avLst/>
           </a:prstGeom>
           <a:solidFill>
-            <a:srgbClr val="38BDF8">
+            <a:srgbClr val="2563EB">
               <a:alpha val="20000"/>
             </a:srgbClr>
           </a:solidFill>
@@ -16446,7 +16446,7 @@
             <a:r>
               <a:rPr lang="en-US" sz="1100" b="1" dirty="0">
                 <a:solidFill>
-                  <a:srgbClr val="38BDF8"/>
+                  <a:srgbClr val="2563EB"/>
                 </a:solidFill>
               </a:rPr>
               <a:t>无 LLM</a:t>
@@ -16470,7 +16470,7 @@
             <a:avLst/>
           </a:prstGeom>
           <a:solidFill>
-            <a:srgbClr val="1E293B"/>
+            <a:srgbClr val="FFFFFF"/>
           </a:solidFill>
           <a:ln/>
           <a:effectLst>
@@ -16497,7 +16497,7 @@
             <a:avLst/>
           </a:prstGeom>
           <a:solidFill>
-            <a:srgbClr val="34D399"/>
+            <a:srgbClr val="059669"/>
           </a:solidFill>
           <a:ln/>
         </p:spPr>
@@ -16517,7 +16517,7 @@
             <a:avLst/>
           </a:prstGeom>
           <a:solidFill>
-            <a:srgbClr val="34D399"/>
+            <a:srgbClr val="059669"/>
           </a:solidFill>
           <a:ln/>
         </p:spPr>
@@ -16549,7 +16549,7 @@
             <a:r>
               <a:rPr lang="en-US" sz="2200" b="1" dirty="0">
                 <a:solidFill>
-                  <a:srgbClr val="0F172A"/>
+                  <a:srgbClr val="FFFFFF"/>
                 </a:solidFill>
               </a:rPr>
               <a:t>2</a:t>
@@ -16585,7 +16585,7 @@
             <a:r>
               <a:rPr lang="en-US" sz="1600" b="1" dirty="0">
                 <a:solidFill>
-                  <a:srgbClr val="34D399"/>
+                  <a:srgbClr val="059669"/>
                 </a:solidFill>
                 <a:latin typeface="Microsoft YaHei" pitchFamily="34" charset="0"/>
                 <a:ea typeface="Microsoft YaHei" pitchFamily="34" charset="-122"/>
@@ -16668,7 +16668,7 @@
             <a:avLst/>
           </a:prstGeom>
           <a:solidFill>
-            <a:srgbClr val="34D399">
+            <a:srgbClr val="059669">
               <a:alpha val="20000"/>
             </a:srgbClr>
           </a:solidFill>
@@ -16702,7 +16702,7 @@
             <a:r>
               <a:rPr lang="en-US" sz="1100" b="1" dirty="0">
                 <a:solidFill>
-                  <a:srgbClr val="34D399"/>
+                  <a:srgbClr val="059669"/>
                 </a:solidFill>
               </a:rPr>
               <a:t>无 LLM</a:t>
@@ -16726,7 +16726,7 @@
             <a:avLst/>
           </a:prstGeom>
           <a:solidFill>
-            <a:srgbClr val="1E293B"/>
+            <a:srgbClr val="FFFFFF"/>
           </a:solidFill>
           <a:ln/>
           <a:effectLst>
@@ -16753,7 +16753,7 @@
             <a:avLst/>
           </a:prstGeom>
           <a:solidFill>
-            <a:srgbClr val="FBBF24"/>
+            <a:srgbClr val="D97706"/>
           </a:solidFill>
           <a:ln/>
         </p:spPr>
@@ -16773,7 +16773,7 @@
             <a:avLst/>
           </a:prstGeom>
           <a:solidFill>
-            <a:srgbClr val="FBBF24"/>
+            <a:srgbClr val="D97706"/>
           </a:solidFill>
           <a:ln/>
         </p:spPr>
@@ -16805,7 +16805,7 @@
             <a:r>
               <a:rPr lang="en-US" sz="2200" b="1" dirty="0">
                 <a:solidFill>
-                  <a:srgbClr val="0F172A"/>
+                  <a:srgbClr val="FFFFFF"/>
                 </a:solidFill>
               </a:rPr>
               <a:t>3</a:t>
@@ -16841,7 +16841,7 @@
             <a:r>
               <a:rPr lang="en-US" sz="1600" b="1" dirty="0">
                 <a:solidFill>
-                  <a:srgbClr val="FBBF24"/>
+                  <a:srgbClr val="D97706"/>
                 </a:solidFill>
                 <a:latin typeface="Microsoft YaHei" pitchFamily="34" charset="0"/>
                 <a:ea typeface="Microsoft YaHei" pitchFamily="34" charset="-122"/>
@@ -16924,7 +16924,7 @@
             <a:avLst/>
           </a:prstGeom>
           <a:solidFill>
-            <a:srgbClr val="FBBF24">
+            <a:srgbClr val="D97706">
               <a:alpha val="20000"/>
             </a:srgbClr>
           </a:solidFill>
@@ -16958,7 +16958,7 @@
             <a:r>
               <a:rPr lang="en-US" sz="1100" b="1" dirty="0">
                 <a:solidFill>
-                  <a:srgbClr val="FBBF24"/>
+                  <a:srgbClr val="D97706"/>
                 </a:solidFill>
               </a:rPr>
               <a:t>可选</a:t>
@@ -16982,7 +16982,7 @@
             <a:avLst/>
           </a:prstGeom>
           <a:solidFill>
-            <a:srgbClr val="1E293B"/>
+            <a:srgbClr val="FFFFFF"/>
           </a:solidFill>
           <a:ln/>
           <a:effectLst>
@@ -17021,7 +17021,7 @@
             <a:r>
               <a:rPr lang="en-US" sz="1200" b="1" dirty="0">
                 <a:solidFill>
-                  <a:srgbClr val="34D399"/>
+                  <a:srgbClr val="059669"/>
                 </a:solidFill>
                 <a:latin typeface="Microsoft YaHei" pitchFamily="34" charset="0"/>
                 <a:ea typeface="Microsoft YaHei" pitchFamily="34" charset="-122"/>
@@ -17060,7 +17060,7 @@
             <a:r>
               <a:rPr lang="en-US" sz="950" dirty="0">
                 <a:solidFill>
-                  <a:srgbClr val="94A3B8"/>
+                  <a:srgbClr val="1E293B"/>
                 </a:solidFill>
                 <a:latin typeface="Microsoft YaHei" pitchFamily="34" charset="0"/>
                 <a:ea typeface="Microsoft YaHei" pitchFamily="34" charset="-122"/>
@@ -17087,7 +17087,7 @@
             <a:avLst/>
           </a:prstGeom>
           <a:solidFill>
-            <a:srgbClr val="F87171"/>
+            <a:srgbClr val="DC2626"/>
           </a:solidFill>
           <a:ln/>
         </p:spPr>
@@ -17119,7 +17119,7 @@
             <a:r>
               <a:rPr lang="en-US" sz="1000" b="1" dirty="0">
                 <a:solidFill>
-                  <a:srgbClr val="F87171"/>
+                  <a:srgbClr val="DC2626"/>
                 </a:solidFill>
                 <a:latin typeface="Microsoft YaHei" pitchFamily="34" charset="0"/>
                 <a:ea typeface="Microsoft YaHei" pitchFamily="34" charset="-122"/>
@@ -17158,7 +17158,7 @@
             <a:r>
               <a:rPr lang="en-US" sz="950" dirty="0">
                 <a:solidFill>
-                  <a:srgbClr val="94A3B8"/>
+                  <a:srgbClr val="1E293B"/>
                 </a:solidFill>
                 <a:latin typeface="Microsoft YaHei" pitchFamily="34" charset="0"/>
                 <a:ea typeface="Microsoft YaHei" pitchFamily="34" charset="-122"/>
@@ -17185,7 +17185,7 @@
             <a:avLst/>
           </a:prstGeom>
           <a:solidFill>
-            <a:srgbClr val="34D399"/>
+            <a:srgbClr val="059669"/>
           </a:solidFill>
           <a:ln/>
         </p:spPr>
@@ -17217,7 +17217,7 @@
             <a:r>
               <a:rPr lang="en-US" sz="1000" b="1" dirty="0">
                 <a:solidFill>
-                  <a:srgbClr val="34D399"/>
+                  <a:srgbClr val="059669"/>
                 </a:solidFill>
                 <a:latin typeface="Microsoft YaHei" pitchFamily="34" charset="0"/>
                 <a:ea typeface="Microsoft YaHei" pitchFamily="34" charset="-122"/>

</xml_diff>